<commit_message>
docs(workshop): record rehearsal deployment and refresh lab materials
Document approved regions and storage exception, current Fabric ontology context, remaining rehearsal limits and teardown ownership. Refresh the MCAPS OpenAPI blocks, TAP instructions, look-only Lab 2 guidance and both generated slide decks.

Co-authored-by: Copilot App <223556219+Copilot@users.noreply.github.com>
</commit_message>
<xml_diff>
--- a/deck/LiveWell-Foundry-Workshop-Day1.pptx
+++ b/deck/LiveWell-Foundry-Workshop-Day1.pptx
@@ -1151,7 +1151,7 @@
           <a:lstStyle/>
           <a:p>
             <a:r>
-              <a:t>Anchor on sponsorship safety: the low path is the intended operating mode, not the high path. Explain that Fabric F2 is cheap during the workshop but expensive if left running all month. Controls are part of the design, not afterthoughts: shared search, small models, caps, budget alerts and teardown. Gate: move on after naming who owns teardown and capacity pause.</a:t>
+              <a:t>Anchor on safety of spend: this is an indicative list-price planning range, not a measurement, and the model meters for gpt-5-mini and gpt-4.1-mini were not confirmed, so check the pricing calculator before quoting a figure. Explain that Fabric F2 is cheap during the workshop but expensive if left running all month. The budget is US$500 on the single resource group with alerts at US$250 and US$500: it is a ceiling that alerts, it does not stop spend, and it is not an approved spend. Controls are part of the design, not afterthoughts: one resource group, shared search, small models, capped units, budget alerts and a teardown that also covers Fabric and the temporary accounts. Gate: move on after naming who owns teardown and capacity pause.</a:t>
             </a:r>
           </a:p>
         </p:txBody>
@@ -1221,7 +1221,7 @@
           <a:lstStyle/>
           <a:p>
             <a:r>
-              <a:t>Keep this slide practical: the workshop repo first, then official repos and Learn titles. Do not send participants to generic marketing pages; these are the artefacts Antonia can merge into the master deck. If URLs are added later, keep them to GitHub or Microsoft Learn. Gate: close the setup section when participants know where the labs and references live.</a:t>
+              <a:t>Keep this slide practical: the workshop repo first, then official repos and Learn titles. The repo is private: Builder participants need a GitHub invite or the release ZIP, because their workshop account does not grant GitHub access. Do not send participants to generic marketing pages; these are the artefacts Antonia can merge into the master deck. If URLs are added later, keep them to GitHub or Microsoft Learn. Gate: close the setup section when participants know where the labs and references live.</a:t>
             </a:r>
           </a:p>
         </p:txBody>
@@ -1431,7 +1431,7 @@
           <a:lstStyle/>
           <a:p>
             <a:r>
-              <a:t>Cover this before anyone opens the portal because sign-in is the first likely delay. Use the TODO labels visibly if the final Wi-Fi values have not been confirmed. Ask participants to use their own workshop account (the username on their sign-in card) for all Foundry and Fabric steps. Gate: move on when everyone has Wi-Fi, Authenticator registration started and the correct account ready.</a:t>
+              <a:t>Cover this before anyone opens the portal because sign-in is the first likely delay. Use the TODO labels visibly if the final Wi-Fi values have not been confirmed. Ask participants to use their own workshop account (the username on their sign-in card) for all Foundry and Fabric steps. The card carries a Temporary Access Pass: a secret, valid only until the printed time; nobody registers Authenticator. If a sign-in page asks for a method to be set up, stop and fetch a facilitator; never weaken a security setting. Gate: move on when everyone has Wi-Fi, Temporary Access Pass entered once and the correct account ready.</a:t>
             </a:r>
           </a:p>
         </p:txBody>
@@ -5783,7 +5783,7 @@
               </a:defRPr>
             </a:pPr>
             <a:r>
-              <a:t>Default vs custom guardrail ladder; block vs annotate; Prompt Shields; self-harm threshold; blocklist; traces; built-in/custom evaluators; version compare; red team.</a:t>
+              <a:t>Default vs custom guardrail ladder; block vs annotate; Prompt Shields; self-harm threshold; blocklist; traces; the facilitator's pre-run evaluation (look-only); version compare; red team (facilitator demo).</a:t>
             </a:r>
           </a:p>
         </p:txBody>
@@ -5855,7 +5855,7 @@
               </a:defRPr>
             </a:pPr>
             <a:r>
-              <a:t>The ladder shows which layer catches each prompt (blocklist, self-harm at Low, Prompt Shields, instructions) and a blocked run appears as Failed in Traces.</a:t>
+              <a:t>The ladder shows which layer catches each prompt (blocklist, self-harm at Low, Prompt Shields, instructions), a blocked run appears as Failed in Traces, and you can read the v1 vs v2 handled_safely result from the prepared evaluation.</a:t>
             </a:r>
           </a:p>
         </p:txBody>
@@ -11715,7 +11715,7 @@
           <a:lstStyle/>
           <a:p>
             <a:pPr algn="ctr">
-              <a:defRPr sz="1150" b="1">
+              <a:defRPr sz="1050" b="1">
                 <a:solidFill>
                   <a:srgbClr val="0B2E59"/>
                 </a:solidFill>
@@ -11723,12 +11723,12 @@
               </a:defRPr>
             </a:pPr>
             <a:r>
-              <a:t>Evaluators</a:t>
+              <a:t>Evaluators (facilitator pre-run, look-only)</a:t>
             </a:r>
           </a:p>
           <a:p>
             <a:pPr algn="ctr">
-              <a:defRPr sz="1150" b="1">
+              <a:defRPr sz="1050" b="1">
                 <a:solidFill>
                   <a:srgbClr val="0B2E59"/>
                 </a:solidFill>
@@ -11736,7 +11736,7 @@
               </a:defRPr>
             </a:pPr>
             <a:r>
-              <a:t>groundedness · relevance · task adherence · tool-call accuracy · intent resolution · custom "advice matches known conditions"</a:t>
+              <a:t>The prepared run scores guardrail_blocked, handled_safely (LLM judge) and self_harm. Built-in families to know: groundedness · relevance · task adherence · tool-call accuracy · intent resolution</a:t>
             </a:r>
           </a:p>
         </p:txBody>
@@ -11783,7 +11783,7 @@
           <a:lstStyle/>
           <a:p>
             <a:pPr algn="ctr">
-              <a:defRPr sz="1300" b="1">
+              <a:defRPr sz="1150" b="1">
                 <a:solidFill>
                   <a:srgbClr val="0B2E59"/>
                 </a:solidFill>
@@ -11796,7 +11796,7 @@
           </a:p>
           <a:p>
             <a:pPr algn="ctr">
-              <a:defRPr sz="1300" b="1">
+              <a:defRPr sz="1150" b="1">
                 <a:solidFill>
                   <a:srgbClr val="0B2E59"/>
                 </a:solidFill>
@@ -11804,12 +11804,12 @@
               </a:defRPr>
             </a:pPr>
             <a:r>
-              <a:t>Facilitator via SDK path</a:t>
+              <a:t>Facilitator only, shown on screen</a:t>
             </a:r>
           </a:p>
           <a:p>
             <a:pPr algn="ctr">
-              <a:defRPr sz="1300" b="1">
+              <a:defRPr sz="1150" b="1">
                 <a:solidFill>
                   <a:srgbClr val="0B2E59"/>
                 </a:solidFill>
@@ -11817,7 +11817,7 @@
               </a:defRPr>
             </a:pPr>
             <a:r>
-              <a:t>approx. US$42 per scan</a:t>
+              <a:t>Paid (approx. US$42 per scan): needs approval; participants run none</a:t>
             </a:r>
           </a:p>
         </p:txBody>
@@ -12046,10 +12046,9 @@
               </a:tblPr>
               <a:tblGrid>
                 <a:gridCol w="4800600"/>
-                <a:gridCol w="914400"/>
-                <a:gridCol w="914400"/>
+                <a:gridCol w="1828800"/>
               </a:tblGrid>
-              <a:tr h="492760">
+              <a:tr h="554355">
                 <a:tc>
                   <a:txBody>
                     <a:bodyPr wrap="square"/>
@@ -12100,37 +12099,7 @@
                           </a:solidFill>
                           <a:latin typeface="Segoe UI"/>
                         </a:rPr>
-                        <a:t>Low</a:t>
-                      </a:r>
-                    </a:p>
-                  </a:txBody>
-                  <a:tcPr marL="36576" marR="36576" marT="18288" marB="18288" anchor="ctr">
-                    <a:solidFill>
-                      <a:srgbClr val="0B2E59"/>
-                    </a:solidFill>
-                  </a:tcPr>
-                </a:tc>
-                <a:tc>
-                  <a:txBody>
-                    <a:bodyPr wrap="square"/>
-                    <a:lstStyle/>
-                    <a:p>
-                      <a:pPr algn="ctr">
-                        <a:defRPr sz="1050" b="1">
-                          <a:solidFill>
-                            <a:srgbClr val="FFFFFF"/>
-                          </a:solidFill>
-                          <a:latin typeface="Segoe UI"/>
-                        </a:defRPr>
-                      </a:pPr>
-                      <a:r>
-                        <a:rPr sz="1050" b="1">
-                          <a:solidFill>
-                            <a:srgbClr val="FFFFFF"/>
-                          </a:solidFill>
-                          <a:latin typeface="Segoe UI"/>
-                        </a:rPr>
-                        <a:t>High</a:t>
+                        <a:t>US$ (indicative)</a:t>
                       </a:r>
                     </a:p>
                   </a:txBody>
@@ -12141,7 +12110,7 @@
                   </a:tcPr>
                 </a:tc>
               </a:tr>
-              <a:tr h="492760">
+              <a:tr h="554355">
                 <a:tc>
                   <a:txBody>
                     <a:bodyPr wrap="square"/>
@@ -12162,7 +12131,7 @@
                           </a:solidFill>
                           <a:latin typeface="Segoe UI"/>
                         </a:rPr>
-                        <a:t>Model tokens (20 x 150 runs x buffer)</a:t>
+                        <a:t>Model tokens, 30 people, pay per token (no participant evaluations)</a:t>
                       </a:r>
                     </a:p>
                   </a:txBody>
@@ -12192,7 +12161,101 @@
                           </a:solidFill>
                           <a:latin typeface="Segoe UI"/>
                         </a:rPr>
-                        <a:t>12</a:t>
+                        <a:t>25-50</a:t>
+                      </a:r>
+                    </a:p>
+                  </a:txBody>
+                  <a:tcPr marL="36576" marR="36576" marT="18288" marB="18288" anchor="ctr">
+                    <a:solidFill>
+                      <a:srgbClr val="FFFFFF"/>
+                    </a:solidFill>
+                  </a:tcPr>
+                </a:tc>
+              </a:tr>
+              <a:tr h="554355">
+                <a:tc>
+                  <a:txBody>
+                    <a:bodyPr wrap="square"/>
+                    <a:lstStyle/>
+                    <a:p>
+                      <a:pPr algn="l">
+                        <a:defRPr sz="969" b="0">
+                          <a:solidFill>
+                            <a:srgbClr val="333333"/>
+                          </a:solidFill>
+                          <a:latin typeface="Segoe UI"/>
+                        </a:defRPr>
+                      </a:pPr>
+                      <a:r>
+                        <a:rPr sz="969" b="0">
+                          <a:solidFill>
+                            <a:srgbClr val="333333"/>
+                          </a:solidFill>
+                          <a:latin typeface="Segoe UI"/>
+                        </a:rPr>
+                        <a:t>Azure AI Search Basic, about 120 h</a:t>
+                      </a:r>
+                    </a:p>
+                  </a:txBody>
+                  <a:tcPr marL="36576" marR="36576" marT="18288" marB="18288" anchor="ctr">
+                    <a:solidFill>
+                      <a:srgbClr val="F7FAFC"/>
+                    </a:solidFill>
+                  </a:tcPr>
+                </a:tc>
+                <a:tc>
+                  <a:txBody>
+                    <a:bodyPr wrap="square"/>
+                    <a:lstStyle/>
+                    <a:p>
+                      <a:pPr algn="l">
+                        <a:defRPr sz="969" b="0">
+                          <a:solidFill>
+                            <a:srgbClr val="333333"/>
+                          </a:solidFill>
+                          <a:latin typeface="Segoe UI"/>
+                        </a:defRPr>
+                      </a:pPr>
+                      <a:r>
+                        <a:rPr sz="969" b="0">
+                          <a:solidFill>
+                            <a:srgbClr val="333333"/>
+                          </a:solidFill>
+                          <a:latin typeface="Segoe UI"/>
+                        </a:rPr>
+                        <a:t>~12</a:t>
+                      </a:r>
+                    </a:p>
+                  </a:txBody>
+                  <a:tcPr marL="36576" marR="36576" marT="18288" marB="18288" anchor="ctr">
+                    <a:solidFill>
+                      <a:srgbClr val="F7FAFC"/>
+                    </a:solidFill>
+                  </a:tcPr>
+                </a:tc>
+              </a:tr>
+              <a:tr h="554355">
+                <a:tc>
+                  <a:txBody>
+                    <a:bodyPr wrap="square"/>
+                    <a:lstStyle/>
+                    <a:p>
+                      <a:pPr algn="l">
+                        <a:defRPr sz="969" b="0">
+                          <a:solidFill>
+                            <a:srgbClr val="333333"/>
+                          </a:solidFill>
+                          <a:latin typeface="Segoe UI"/>
+                        </a:defRPr>
+                      </a:pPr>
+                      <a:r>
+                        <a:rPr sz="969" b="0">
+                          <a:solidFill>
+                            <a:srgbClr val="333333"/>
+                          </a:solidFill>
+                          <a:latin typeface="Segoe UI"/>
+                        </a:rPr>
+                        <a:t>Fabric F2, 16-24 h active (about US$0.36/h)</a:t>
                       </a:r>
                     </a:p>
                   </a:txBody>
@@ -12222,7 +12285,7 @@
                           </a:solidFill>
                           <a:latin typeface="Segoe UI"/>
                         </a:rPr>
-                        <a:t>60</a:t>
+                        <a:t>6-9</a:t>
                       </a:r>
                     </a:p>
                   </a:txBody>
@@ -12233,7 +12296,7 @@
                   </a:tcPr>
                 </a:tc>
               </a:tr>
-              <a:tr h="492760">
+              <a:tr h="554355">
                 <a:tc>
                   <a:txBody>
                     <a:bodyPr wrap="square"/>
@@ -12254,7 +12317,7 @@
                           </a:solidFill>
                           <a:latin typeface="Segoe UI"/>
                         </a:rPr>
-                        <a:t>Quality evaluations</a:t>
+                        <a:t>Container Apps, ACR, logs, storage, App Insights, judge tokens</a:t>
                       </a:r>
                     </a:p>
                   </a:txBody>
@@ -12284,7 +12347,101 @@
                           </a:solidFill>
                           <a:latin typeface="Segoe UI"/>
                         </a:rPr>
-                        <a:t>4</a:t>
+                        <a:t>small, not itemised</a:t>
+                      </a:r>
+                    </a:p>
+                  </a:txBody>
+                  <a:tcPr marL="36576" marR="36576" marT="18288" marB="18288" anchor="ctr">
+                    <a:solidFill>
+                      <a:srgbClr val="F7FAFC"/>
+                    </a:solidFill>
+                  </a:tcPr>
+                </a:tc>
+              </a:tr>
+              <a:tr h="554355">
+                <a:tc>
+                  <a:txBody>
+                    <a:bodyPr wrap="square"/>
+                    <a:lstStyle/>
+                    <a:p>
+                      <a:pPr algn="l">
+                        <a:defRPr sz="969" b="0">
+                          <a:solidFill>
+                            <a:srgbClr val="333333"/>
+                          </a:solidFill>
+                          <a:latin typeface="Segoe UI"/>
+                        </a:defRPr>
+                      </a:pPr>
+                      <a:r>
+                        <a:rPr sz="969" b="0">
+                          <a:solidFill>
+                            <a:srgbClr val="333333"/>
+                          </a:solidFill>
+                          <a:latin typeface="Segoe UI"/>
+                        </a:rPr>
+                        <a:t>Planning range for the whole window, with buffer</a:t>
+                      </a:r>
+                    </a:p>
+                  </a:txBody>
+                  <a:tcPr marL="36576" marR="36576" marT="18288" marB="18288" anchor="ctr">
+                    <a:solidFill>
+                      <a:srgbClr val="FFFFFF"/>
+                    </a:solidFill>
+                  </a:tcPr>
+                </a:tc>
+                <a:tc>
+                  <a:txBody>
+                    <a:bodyPr wrap="square"/>
+                    <a:lstStyle/>
+                    <a:p>
+                      <a:pPr algn="l">
+                        <a:defRPr sz="969" b="0">
+                          <a:solidFill>
+                            <a:srgbClr val="333333"/>
+                          </a:solidFill>
+                          <a:latin typeface="Segoe UI"/>
+                        </a:defRPr>
+                      </a:pPr>
+                      <a:r>
+                        <a:rPr sz="969" b="0">
+                          <a:solidFill>
+                            <a:srgbClr val="333333"/>
+                          </a:solidFill>
+                          <a:latin typeface="Segoe UI"/>
+                        </a:rPr>
+                        <a:t>approx. 100-160</a:t>
+                      </a:r>
+                    </a:p>
+                  </a:txBody>
+                  <a:tcPr marL="36576" marR="36576" marT="18288" marB="18288" anchor="ctr">
+                    <a:solidFill>
+                      <a:srgbClr val="FFFFFF"/>
+                    </a:solidFill>
+                  </a:tcPr>
+                </a:tc>
+              </a:tr>
+              <a:tr h="554355">
+                <a:tc>
+                  <a:txBody>
+                    <a:bodyPr wrap="square"/>
+                    <a:lstStyle/>
+                    <a:p>
+                      <a:pPr algn="l">
+                        <a:defRPr sz="969" b="0">
+                          <a:solidFill>
+                            <a:srgbClr val="333333"/>
+                          </a:solidFill>
+                          <a:latin typeface="Segoe UI"/>
+                        </a:defRPr>
+                      </a:pPr>
+                      <a:r>
+                        <a:rPr sz="969" b="0">
+                          <a:solidFill>
+                            <a:srgbClr val="333333"/>
+                          </a:solidFill>
+                          <a:latin typeface="Segoe UI"/>
+                        </a:rPr>
+                        <a:t>Facilitator red-team scan (separate approval)</a:t>
                       </a:r>
                     </a:p>
                   </a:txBody>
@@ -12314,7 +12471,7 @@
                           </a:solidFill>
                           <a:latin typeface="Segoe UI"/>
                         </a:rPr>
-                        <a:t>4</a:t>
+                        <a:t>+42 per documented scan</a:t>
                       </a:r>
                     </a:p>
                   </a:txBody>
@@ -12325,7 +12482,7 @@
                   </a:tcPr>
                 </a:tc>
               </a:tr>
-              <a:tr h="492760">
+              <a:tr h="554355">
                 <a:tc>
                   <a:txBody>
                     <a:bodyPr wrap="square"/>
@@ -12346,7 +12503,7 @@
                           </a:solidFill>
                           <a:latin typeface="Segoe UI"/>
                         </a:rPr>
-                        <a:t>Red teaming / safety evals</a:t>
+                        <a:t>Participants run evaluations or red teaming</a:t>
                       </a:r>
                     </a:p>
                   </a:txBody>
@@ -12376,37 +12533,7 @@
                           </a:solidFill>
                           <a:latin typeface="Segoe UI"/>
                         </a:rPr>
-                        <a:t>42</a:t>
-                      </a:r>
-                    </a:p>
-                  </a:txBody>
-                  <a:tcPr marL="36576" marR="36576" marT="18288" marB="18288" anchor="ctr">
-                    <a:solidFill>
-                      <a:srgbClr val="FFFFFF"/>
-                    </a:solidFill>
-                  </a:tcPr>
-                </a:tc>
-                <a:tc>
-                  <a:txBody>
-                    <a:bodyPr wrap="square"/>
-                    <a:lstStyle/>
-                    <a:p>
-                      <a:pPr algn="l">
-                        <a:defRPr sz="969" b="0">
-                          <a:solidFill>
-                            <a:srgbClr val="333333"/>
-                          </a:solidFill>
-                          <a:latin typeface="Segoe UI"/>
-                        </a:defRPr>
-                      </a:pPr>
-                      <a:r>
-                        <a:rPr sz="969" b="0">
-                          <a:solidFill>
-                            <a:srgbClr val="333333"/>
-                          </a:solidFill>
-                          <a:latin typeface="Segoe UI"/>
-                        </a:rPr>
-                        <a:t>42</a:t>
+                        <a:t>not allowed</a:t>
                       </a:r>
                     </a:p>
                   </a:txBody>
@@ -12417,466 +12544,6 @@
                   </a:tcPr>
                 </a:tc>
               </a:tr>
-              <a:tr h="492760">
-                <a:tc>
-                  <a:txBody>
-                    <a:bodyPr wrap="square"/>
-                    <a:lstStyle/>
-                    <a:p>
-                      <a:pPr algn="l">
-                        <a:defRPr sz="969" b="0">
-                          <a:solidFill>
-                            <a:srgbClr val="333333"/>
-                          </a:solidFill>
-                          <a:latin typeface="Segoe UI"/>
-                        </a:defRPr>
-                      </a:pPr>
-                      <a:r>
-                        <a:rPr sz="969" b="0">
-                          <a:solidFill>
-                            <a:srgbClr val="333333"/>
-                          </a:solidFill>
-                          <a:latin typeface="Segoe UI"/>
-                        </a:rPr>
-                        <a:t>Azure AI Search, 120 h</a:t>
-                      </a:r>
-                    </a:p>
-                  </a:txBody>
-                  <a:tcPr marL="36576" marR="36576" marT="18288" marB="18288" anchor="ctr">
-                    <a:solidFill>
-                      <a:srgbClr val="F7FAFC"/>
-                    </a:solidFill>
-                  </a:tcPr>
-                </a:tc>
-                <a:tc>
-                  <a:txBody>
-                    <a:bodyPr wrap="square"/>
-                    <a:lstStyle/>
-                    <a:p>
-                      <a:pPr algn="l">
-                        <a:defRPr sz="969" b="0">
-                          <a:solidFill>
-                            <a:srgbClr val="333333"/>
-                          </a:solidFill>
-                          <a:latin typeface="Segoe UI"/>
-                        </a:defRPr>
-                      </a:pPr>
-                      <a:r>
-                        <a:rPr sz="969" b="0">
-                          <a:solidFill>
-                            <a:srgbClr val="333333"/>
-                          </a:solidFill>
-                          <a:latin typeface="Segoe UI"/>
-                        </a:rPr>
-                        <a:t>12</a:t>
-                      </a:r>
-                    </a:p>
-                  </a:txBody>
-                  <a:tcPr marL="36576" marR="36576" marT="18288" marB="18288" anchor="ctr">
-                    <a:solidFill>
-                      <a:srgbClr val="F7FAFC"/>
-                    </a:solidFill>
-                  </a:tcPr>
-                </a:tc>
-                <a:tc>
-                  <a:txBody>
-                    <a:bodyPr wrap="square"/>
-                    <a:lstStyle/>
-                    <a:p>
-                      <a:pPr algn="l">
-                        <a:defRPr sz="969" b="0">
-                          <a:solidFill>
-                            <a:srgbClr val="333333"/>
-                          </a:solidFill>
-                          <a:latin typeface="Segoe UI"/>
-                        </a:defRPr>
-                      </a:pPr>
-                      <a:r>
-                        <a:rPr sz="969" b="0">
-                          <a:solidFill>
-                            <a:srgbClr val="333333"/>
-                          </a:solidFill>
-                          <a:latin typeface="Segoe UI"/>
-                        </a:rPr>
-                        <a:t>40</a:t>
-                      </a:r>
-                    </a:p>
-                  </a:txBody>
-                  <a:tcPr marL="36576" marR="36576" marT="18288" marB="18288" anchor="ctr">
-                    <a:solidFill>
-                      <a:srgbClr val="F7FAFC"/>
-                    </a:solidFill>
-                  </a:tcPr>
-                </a:tc>
-              </a:tr>
-              <a:tr h="492760">
-                <a:tc>
-                  <a:txBody>
-                    <a:bodyPr wrap="square"/>
-                    <a:lstStyle/>
-                    <a:p>
-                      <a:pPr algn="l">
-                        <a:defRPr sz="969" b="0">
-                          <a:solidFill>
-                            <a:srgbClr val="333333"/>
-                          </a:solidFill>
-                          <a:latin typeface="Segoe UI"/>
-                        </a:defRPr>
-                      </a:pPr>
-                      <a:r>
-                        <a:rPr sz="969" b="0">
-                          <a:solidFill>
-                            <a:srgbClr val="333333"/>
-                          </a:solidFill>
-                          <a:latin typeface="Segoe UI"/>
-                        </a:rPr>
-                        <a:t>Semantic ranker, Bing, Code Interpreter, hosted agents, ACR, storage/App Insights</a:t>
-                      </a:r>
-                    </a:p>
-                  </a:txBody>
-                  <a:tcPr marL="36576" marR="36576" marT="18288" marB="18288" anchor="ctr">
-                    <a:solidFill>
-                      <a:srgbClr val="FFFFFF"/>
-                    </a:solidFill>
-                  </a:tcPr>
-                </a:tc>
-                <a:tc>
-                  <a:txBody>
-                    <a:bodyPr wrap="square"/>
-                    <a:lstStyle/>
-                    <a:p>
-                      <a:pPr algn="l">
-                        <a:defRPr sz="969" b="0">
-                          <a:solidFill>
-                            <a:srgbClr val="333333"/>
-                          </a:solidFill>
-                          <a:latin typeface="Segoe UI"/>
-                        </a:defRPr>
-                      </a:pPr>
-                      <a:r>
-                        <a:rPr sz="969" b="0">
-                          <a:solidFill>
-                            <a:srgbClr val="333333"/>
-                          </a:solidFill>
-                          <a:latin typeface="Segoe UI"/>
-                        </a:rPr>
-                        <a:t>~12</a:t>
-                      </a:r>
-                    </a:p>
-                  </a:txBody>
-                  <a:tcPr marL="36576" marR="36576" marT="18288" marB="18288" anchor="ctr">
-                    <a:solidFill>
-                      <a:srgbClr val="FFFFFF"/>
-                    </a:solidFill>
-                  </a:tcPr>
-                </a:tc>
-                <a:tc>
-                  <a:txBody>
-                    <a:bodyPr wrap="square"/>
-                    <a:lstStyle/>
-                    <a:p>
-                      <a:pPr algn="l">
-                        <a:defRPr sz="969" b="0">
-                          <a:solidFill>
-                            <a:srgbClr val="333333"/>
-                          </a:solidFill>
-                          <a:latin typeface="Segoe UI"/>
-                        </a:defRPr>
-                      </a:pPr>
-                      <a:r>
-                        <a:rPr sz="969" b="0">
-                          <a:solidFill>
-                            <a:srgbClr val="333333"/>
-                          </a:solidFill>
-                          <a:latin typeface="Segoe UI"/>
-                        </a:rPr>
-                        <a:t>~18</a:t>
-                      </a:r>
-                    </a:p>
-                  </a:txBody>
-                  <a:tcPr marL="36576" marR="36576" marT="18288" marB="18288" anchor="ctr">
-                    <a:solidFill>
-                      <a:srgbClr val="FFFFFF"/>
-                    </a:solidFill>
-                  </a:tcPr>
-                </a:tc>
-              </a:tr>
-              <a:tr h="492760">
-                <a:tc>
-                  <a:txBody>
-                    <a:bodyPr wrap="square"/>
-                    <a:lstStyle/>
-                    <a:p>
-                      <a:pPr algn="l">
-                        <a:defRPr sz="969" b="0">
-                          <a:solidFill>
-                            <a:srgbClr val="333333"/>
-                          </a:solidFill>
-                          <a:latin typeface="Segoe UI"/>
-                        </a:defRPr>
-                      </a:pPr>
-                      <a:r>
-                        <a:rPr sz="969" b="0">
-                          <a:solidFill>
-                            <a:srgbClr val="333333"/>
-                          </a:solidFill>
-                          <a:latin typeface="Segoe UI"/>
-                        </a:rPr>
-                        <a:t>Total</a:t>
-                      </a:r>
-                    </a:p>
-                  </a:txBody>
-                  <a:tcPr marL="36576" marR="36576" marT="18288" marB="18288" anchor="ctr">
-                    <a:solidFill>
-                      <a:srgbClr val="F7FAFC"/>
-                    </a:solidFill>
-                  </a:tcPr>
-                </a:tc>
-                <a:tc>
-                  <a:txBody>
-                    <a:bodyPr wrap="square"/>
-                    <a:lstStyle/>
-                    <a:p>
-                      <a:pPr algn="l">
-                        <a:defRPr sz="969" b="0">
-                          <a:solidFill>
-                            <a:srgbClr val="333333"/>
-                          </a:solidFill>
-                          <a:latin typeface="Segoe UI"/>
-                        </a:defRPr>
-                      </a:pPr>
-                      <a:r>
-                        <a:rPr sz="969" b="0">
-                          <a:solidFill>
-                            <a:srgbClr val="333333"/>
-                          </a:solidFill>
-                          <a:latin typeface="Segoe UI"/>
-                        </a:rPr>
-                        <a:t>approx. 83</a:t>
-                      </a:r>
-                    </a:p>
-                  </a:txBody>
-                  <a:tcPr marL="36576" marR="36576" marT="18288" marB="18288" anchor="ctr">
-                    <a:solidFill>
-                      <a:srgbClr val="F7FAFC"/>
-                    </a:solidFill>
-                  </a:tcPr>
-                </a:tc>
-                <a:tc>
-                  <a:txBody>
-                    <a:bodyPr wrap="square"/>
-                    <a:lstStyle/>
-                    <a:p>
-                      <a:pPr algn="l">
-                        <a:defRPr sz="969" b="0">
-                          <a:solidFill>
-                            <a:srgbClr val="333333"/>
-                          </a:solidFill>
-                          <a:latin typeface="Segoe UI"/>
-                        </a:defRPr>
-                      </a:pPr>
-                      <a:r>
-                        <a:rPr sz="969" b="0">
-                          <a:solidFill>
-                            <a:srgbClr val="333333"/>
-                          </a:solidFill>
-                          <a:latin typeface="Segoe UI"/>
-                        </a:rPr>
-                        <a:t>approx. 166</a:t>
-                      </a:r>
-                    </a:p>
-                  </a:txBody>
-                  <a:tcPr marL="36576" marR="36576" marT="18288" marB="18288" anchor="ctr">
-                    <a:solidFill>
-                      <a:srgbClr val="F7FAFC"/>
-                    </a:solidFill>
-                  </a:tcPr>
-                </a:tc>
-              </a:tr>
-              <a:tr h="492760">
-                <a:tc>
-                  <a:txBody>
-                    <a:bodyPr wrap="square"/>
-                    <a:lstStyle/>
-                    <a:p>
-                      <a:pPr algn="l">
-                        <a:defRPr sz="969" b="0">
-                          <a:solidFill>
-                            <a:srgbClr val="333333"/>
-                          </a:solidFill>
-                          <a:latin typeface="Segoe UI"/>
-                        </a:defRPr>
-                      </a:pPr>
-                      <a:r>
-                        <a:rPr sz="969" b="0">
-                          <a:solidFill>
-                            <a:srgbClr val="333333"/>
-                          </a:solidFill>
-                          <a:latin typeface="Segoe UI"/>
-                        </a:rPr>
-                        <a:t>Every participant runs a full red-team scan</a:t>
-                      </a:r>
-                    </a:p>
-                  </a:txBody>
-                  <a:tcPr marL="36576" marR="36576" marT="18288" marB="18288" anchor="ctr">
-                    <a:solidFill>
-                      <a:srgbClr val="FFFFFF"/>
-                    </a:solidFill>
-                  </a:tcPr>
-                </a:tc>
-                <a:tc>
-                  <a:txBody>
-                    <a:bodyPr wrap="square"/>
-                    <a:lstStyle/>
-                    <a:p>
-                      <a:pPr algn="l">
-                        <a:defRPr sz="969" b="0">
-                          <a:solidFill>
-                            <a:srgbClr val="333333"/>
-                          </a:solidFill>
-                          <a:latin typeface="Segoe UI"/>
-                        </a:defRPr>
-                      </a:pPr>
-                      <a:r>
-                        <a:rPr sz="969" b="0">
-                          <a:solidFill>
-                            <a:srgbClr val="333333"/>
-                          </a:solidFill>
-                          <a:latin typeface="Segoe UI"/>
-                        </a:rPr>
-                        <a:t>+126</a:t>
-                      </a:r>
-                    </a:p>
-                  </a:txBody>
-                  <a:tcPr marL="36576" marR="36576" marT="18288" marB="18288" anchor="ctr">
-                    <a:solidFill>
-                      <a:srgbClr val="FFFFFF"/>
-                    </a:solidFill>
-                  </a:tcPr>
-                </a:tc>
-                <a:tc>
-                  <a:txBody>
-                    <a:bodyPr wrap="square"/>
-                    <a:lstStyle/>
-                    <a:p>
-                      <a:pPr algn="l">
-                        <a:defRPr sz="969" b="0">
-                          <a:solidFill>
-                            <a:srgbClr val="333333"/>
-                          </a:solidFill>
-                          <a:latin typeface="Segoe UI"/>
-                        </a:defRPr>
-                      </a:pPr>
-                      <a:r>
-                        <a:rPr sz="969" b="0">
-                          <a:solidFill>
-                            <a:srgbClr val="333333"/>
-                          </a:solidFill>
-                          <a:latin typeface="Segoe UI"/>
-                        </a:rPr>
-                        <a:t>approx. 292</a:t>
-                      </a:r>
-                    </a:p>
-                  </a:txBody>
-                  <a:tcPr marL="36576" marR="36576" marT="18288" marB="18288" anchor="ctr">
-                    <a:solidFill>
-                      <a:srgbClr val="FFFFFF"/>
-                    </a:solidFill>
-                  </a:tcPr>
-                </a:tc>
-              </a:tr>
-              <a:tr h="492760">
-                <a:tc>
-                  <a:txBody>
-                    <a:bodyPr wrap="square"/>
-                    <a:lstStyle/>
-                    <a:p>
-                      <a:pPr algn="l">
-                        <a:defRPr sz="969" b="0">
-                          <a:solidFill>
-                            <a:srgbClr val="333333"/>
-                          </a:solidFill>
-                          <a:latin typeface="Segoe UI"/>
-                        </a:defRPr>
-                      </a:pPr>
-                      <a:r>
-                        <a:rPr sz="969" b="0">
-                          <a:solidFill>
-                            <a:srgbClr val="333333"/>
-                          </a:solidFill>
-                          <a:latin typeface="Segoe UI"/>
-                        </a:rPr>
-                        <a:t>Fabric F2, 16 h active</a:t>
-                      </a:r>
-                    </a:p>
-                  </a:txBody>
-                  <a:tcPr marL="36576" marR="36576" marT="18288" marB="18288" anchor="ctr">
-                    <a:solidFill>
-                      <a:srgbClr val="F7FAFC"/>
-                    </a:solidFill>
-                  </a:tcPr>
-                </a:tc>
-                <a:tc>
-                  <a:txBody>
-                    <a:bodyPr wrap="square"/>
-                    <a:lstStyle/>
-                    <a:p>
-                      <a:pPr algn="l">
-                        <a:defRPr sz="969" b="0">
-                          <a:solidFill>
-                            <a:srgbClr val="333333"/>
-                          </a:solidFill>
-                          <a:latin typeface="Segoe UI"/>
-                        </a:defRPr>
-                      </a:pPr>
-                      <a:r>
-                        <a:rPr sz="969" b="0">
-                          <a:solidFill>
-                            <a:srgbClr val="333333"/>
-                          </a:solidFill>
-                          <a:latin typeface="Segoe UI"/>
-                        </a:rPr>
-                        <a:t>+6</a:t>
-                      </a:r>
-                    </a:p>
-                  </a:txBody>
-                  <a:tcPr marL="36576" marR="36576" marT="18288" marB="18288" anchor="ctr">
-                    <a:solidFill>
-                      <a:srgbClr val="F7FAFC"/>
-                    </a:solidFill>
-                  </a:tcPr>
-                </a:tc>
-                <a:tc>
-                  <a:txBody>
-                    <a:bodyPr wrap="square"/>
-                    <a:lstStyle/>
-                    <a:p>
-                      <a:pPr algn="l">
-                        <a:defRPr sz="969" b="0">
-                          <a:solidFill>
-                            <a:srgbClr val="333333"/>
-                          </a:solidFill>
-                          <a:latin typeface="Segoe UI"/>
-                        </a:defRPr>
-                      </a:pPr>
-                      <a:r>
-                        <a:rPr sz="969" b="0">
-                          <a:solidFill>
-                            <a:srgbClr val="333333"/>
-                          </a:solidFill>
-                          <a:latin typeface="Segoe UI"/>
-                        </a:rPr>
-                        <a:t>+6</a:t>
-                      </a:r>
-                    </a:p>
-                  </a:txBody>
-                  <a:tcPr marL="36576" marR="36576" marT="18288" marB="18288" anchor="ctr">
-                    <a:solidFill>
-                      <a:srgbClr val="F7FAFC"/>
-                    </a:solidFill>
-                  </a:tcPr>
-                </a:tc>
-              </a:tr>
             </a:tbl>
           </a:graphicData>
         </a:graphic>
@@ -12945,7 +12612,7 @@
         <p:spPr>
           <a:xfrm>
             <a:off x="7543800" y="1691640"/>
-            <a:ext cx="3977639" cy="2377440"/>
+            <a:ext cx="3977639" cy="2743200"/>
           </a:xfrm>
           <a:prstGeom prst="rect">
             <a:avLst/>
@@ -12959,7 +12626,7 @@
           <a:lstStyle/>
           <a:p>
             <a:pPr algn="l">
-              <a:defRPr sz="1220" b="0">
+              <a:defRPr sz="1160" b="0">
                 <a:solidFill>
                   <a:srgbClr val="333333"/>
                 </a:solidFill>
@@ -12967,12 +12634,12 @@
               </a:defRPr>
             </a:pPr>
             <a:r>
-              <a:t>• One shared search service and KB</a:t>
+              <a:t>• One resource group in swedencentral; one shared search service and KB</a:t>
             </a:r>
           </a:p>
           <a:p>
             <a:pPr algn="l">
-              <a:defRPr sz="1220" b="0">
+              <a:defRPr sz="1160" b="0">
                 <a:solidFill>
                   <a:srgbClr val="333333"/>
                 </a:solidFill>
@@ -12980,12 +12647,12 @@
               </a:defRPr>
             </a:pPr>
             <a:r>
-              <a:t>• gpt-5-mini default (reasoning Low); TPM caps; no PTU</a:t>
+              <a:t>• gpt-5-mini default (reasoning Low), gpt-4.1-mini tools; capped units; no PTU, no model-router</a:t>
             </a:r>
           </a:p>
           <a:p>
             <a:pPr algn="l">
-              <a:defRPr sz="1220" b="0">
+              <a:defRPr sz="1160" b="0">
                 <a:solidFill>
                   <a:srgbClr val="333333"/>
                 </a:solidFill>
@@ -12993,12 +12660,12 @@
               </a:defRPr>
             </a:pPr>
             <a:r>
-              <a:t>• Red teaming facilitator-run; lite scan only if enabled</a:t>
+              <a:t>• Lab 2 is look-only: participants run no evaluation or red team</a:t>
             </a:r>
           </a:p>
           <a:p>
             <a:pPr algn="l">
-              <a:defRPr sz="1220" b="0">
+              <a:defRPr sz="1160" b="0">
                 <a:solidFill>
                   <a:srgbClr val="333333"/>
                 </a:solidFill>
@@ -13006,12 +12673,12 @@
               </a:defRPr>
             </a:pPr>
             <a:r>
-              <a:t>• Bing off by default; budgets at US$150 and US$300</a:t>
+              <a:t>• Bing off by default; budget US$500, alerts at US$250 and US$500</a:t>
             </a:r>
           </a:p>
           <a:p>
             <a:pPr algn="l">
-              <a:defRPr sz="1220" b="0">
+              <a:defRPr sz="1160" b="0">
                 <a:solidFill>
                   <a:srgbClr val="333333"/>
                 </a:solidFill>
@@ -13019,7 +12686,7 @@
               </a:defRPr>
             </a:pPr>
             <a:r>
-              <a:t>• Fabric capacity paused nightly; teardown at T+1</a:t>
+              <a:t>• Fabric F2 paused when idle; teardown at T+1 incl. Fabric workspace and temporary accounts</a:t>
             </a:r>
           </a:p>
         </p:txBody>
@@ -13087,7 +12754,7 @@
               </a:defRPr>
             </a:pPr>
             <a:r>
-              <a:t>approx. US$0.36/h; approx. US$259/month if left on; F4 doubles it</a:t>
+              <a:t>approx. US$0.36/h; approx. US$259/month if left on; resizing needs approval</a:t>
             </a:r>
           </a:p>
         </p:txBody>
@@ -13382,7 +13049,7 @@
               </a:defRPr>
             </a:pPr>
             <a:r>
-              <a:t>tonirex/livewell-foundry-workshop</a:t>
+              <a:t>github.com/tonirex/hpb-foundry-workshop</a:t>
             </a:r>
           </a:p>
           <a:p>
@@ -13395,7 +13062,7 @@
               </a:defRPr>
             </a:pPr>
             <a:r>
-              <a:t>private until the dry run passes</a:t>
+              <a:t>private: the facilitator invites your GitHub username</a:t>
             </a:r>
           </a:p>
         </p:txBody>
@@ -17359,7 +17026,7 @@
                           </a:solidFill>
                           <a:latin typeface="Segoe UI"/>
                         </a:rPr>
-                        <a:t>Guardrails, evaluators, red-team scan, RBAC, Entra Agent ID</a:t>
+                        <a:t>Guardrails, evaluators (pre-run, facilitator), red-team demo (facilitator), RBAC, Entra Agent ID</a:t>
                       </a:r>
                     </a:p>
                   </a:txBody>
@@ -18033,7 +17700,7 @@
               </a:defRPr>
             </a:pPr>
             <a:r>
-              <a:t>• Authenticator registration happens at first sign-in; keep the phone nearby.</a:t>
+              <a:t>• Enter the Temporary Access Pass from your card as the password; there is no Authenticator to register.</a:t>
             </a:r>
           </a:p>
           <a:p>

</xml_diff>

<commit_message>
feat(workshop): unify participant guides and copy blocks
Consolidate Navigator walkthroughs, render canonical inline payloads, align learning evidence, and validate participant navigation and assets. Apply the approved text-only fallback for archived captures without claiming live retakes.

Co-authored-by: Copilot App <223556219+Copilot@users.noreply.github.com>
</commit_message>
<xml_diff>
--- a/deck/LiveWell-Foundry-Workshop-Day1.pptx
+++ b/deck/LiveWell-Foundry-Workshop-Day1.pptx
@@ -6567,7 +6567,7 @@
               </a:defRPr>
             </a:pPr>
             <a:r>
-              <a:t>livewell_profile OpenAPI tool (get_citizen_profile function in Builder); activities MCP; approval-before-write; memory; connected specialists.</a:t>
+              <a:t>livewell_profile OpenAPI tool (get_citizen_profile function in Builder); activities MCP; approval-before-write; memory; optional A2A specialists.</a:t>
             </a:r>
           </a:p>
         </p:txBody>
@@ -7792,7 +7792,7 @@
               </a:defRPr>
             </a:pPr>
             <a:r>
-              <a:t>Builder</a:t>
+              <a:t>Navigator / Builder</a:t>
             </a:r>
           </a:p>
         </p:txBody>
@@ -7919,7 +7919,7 @@
               </a:defRPr>
             </a:pPr>
             <a:r>
-              <a:t>Engineer appendix · facilitator demo</a:t>
+              <a:t>Browser hands-on · facilitator deploy</a:t>
             </a:r>
           </a:p>
         </p:txBody>
@@ -13360,7 +13360,7 @@
         <p:spPr>
           <a:xfrm>
             <a:off x="777240" y="1783080"/>
-            <a:ext cx="4892040" cy="457200"/>
+            <a:ext cx="4892040" cy="594360"/>
           </a:xfrm>
           <a:prstGeom prst="rect">
             <a:avLst/>
@@ -13374,7 +13374,7 @@
           <a:lstStyle/>
           <a:p>
             <a:pPr algn="l">
-              <a:defRPr sz="1400" b="0">
+              <a:defRPr sz="1300" b="0">
                 <a:solidFill>
                   <a:srgbClr val="333333"/>
                 </a:solidFill>
@@ -13382,12 +13382,12 @@
               </a:defRPr>
             </a:pPr>
             <a:r>
-              <a:t>tonirex/livewell-foundry-workshop</a:t>
+              <a:t>https://github.com/tonirex/hpb-foundry-workshop</a:t>
             </a:r>
           </a:p>
           <a:p>
             <a:pPr algn="l">
-              <a:defRPr sz="1400" b="0">
+              <a:defRPr sz="1300" b="0">
                 <a:solidFill>
                   <a:srgbClr val="333333"/>
                 </a:solidFill>
@@ -13395,7 +13395,7 @@
               </a:defRPr>
             </a:pPr>
             <a:r>
-              <a:t>private until the dry run passes</a:t>
+              <a:t>One lab page: Navigator + Builder</a:t>
             </a:r>
           </a:p>
         </p:txBody>
@@ -21802,7 +21802,7 @@
               </a:defRPr>
             </a:pPr>
             <a:r>
-              <a:t>• Memory (preview) and connected agents / Agent Framework</a:t>
+              <a:t>• Memory (preview); A2A specialists / Agent Framework</a:t>
             </a:r>
           </a:p>
           <a:p>

</xml_diff>

<commit_message>
fix(lab2): separate evaluation from participant runs
Co-authored-by: Copilot App <223556219+Copilot@users.noreply.github.com>
</commit_message>
<xml_diff>
--- a/deck/LiveWell-Foundry-Workshop-Day1.pptx
+++ b/deck/LiveWell-Foundry-Workshop-Day1.pptx
@@ -1081,7 +1081,7 @@
           <a:lstStyle/>
           <a:p>
             <a:r>
-              <a:t>Run the default and custom ladder live if the environment is healthy; otherwise use the pre-captured traces. The result columns are the expected outcomes from Lab 2: the custom policy moves guardrail blocks from 1 of 7 to 4 of 7. Explain block versus annotate: at or above the threshold the request is blocked (HTTP 400, red banner, Failed trace); below it the answer goes through and the severity is recorded. The dose-reminder row is the cost of a stricter control. Gate: move on when every table has at least one production policy they would require.</a:t>
+              <a:t>Run the default and custom ladder live if the environment is healthy; otherwise use the pre-captured traces. The result columns are the expected outcomes from Lab 2: the custom policy moves guardrail blocks from 1 of 7 to 4 of 7. Explain block versus annotate: at or above the threshold the request is blocked (HTTP 400, red banner, Failed trace); below it the answer goes through and the severity is recorded. The dose-reminder row is the cost of a stricter control. Batch evaluation is a code walkthrough, not a participant run: show the completed shared v1/v2 results. Launching several judges per row across the room can exhaust quota and exceed the lab time. Gate: move on when every table has at least one production policy they would require.</a:t>
             </a:r>
           </a:p>
         </p:txBody>
@@ -5783,7 +5783,7 @@
               </a:defRPr>
             </a:pPr>
             <a:r>
-              <a:t>Default vs custom guardrail ladder; block vs annotate; Prompt Shields; self-harm threshold; blocklist; traces; built-in/custom evaluators; version compare; red team.</a:t>
+              <a:t>Guardrail ladder; block vs annotate; Prompt Shields; thresholds; blocklist; traces; evaluation code walkthrough and shared version comparison; red team.</a:t>
             </a:r>
           </a:p>
         </p:txBody>
@@ -5855,7 +5855,7 @@
               </a:defRPr>
             </a:pPr>
             <a:r>
-              <a:t>The ladder shows which layer catches each prompt (blocklist, self-harm at Low, Prompt Shields, instructions) and a blocked run appears as Failed in Traces.</a:t>
+              <a:t>Inspect blocked/allowed traces and explain a trade-off in the facilitator's completed evaluation. Read the evaluation code; do not run a batch during the lab.</a:t>
             </a:r>
           </a:p>
         </p:txBody>
@@ -11723,7 +11723,7 @@
               </a:defRPr>
             </a:pPr>
             <a:r>
-              <a:t>Evaluators</a:t>
+              <a:t>Evaluators · read, do not run</a:t>
             </a:r>
           </a:p>
           <a:p>
@@ -11736,7 +11736,20 @@
               </a:defRPr>
             </a:pPr>
             <a:r>
-              <a:t>groundedness · relevance · task adherence · tool-call accuracy · intent resolution · custom "advice matches known conditions"</a:t>
+              <a:t>Review the shared completed comparison:</a:t>
+            </a:r>
+          </a:p>
+          <a:p>
+            <a:pPr algn="ctr">
+              <a:defRPr sz="1150" b="1">
+                <a:solidFill>
+                  <a:srgbClr val="0B2E59"/>
+                </a:solidFill>
+                <a:latin typeface="Segoe UI"/>
+              </a:defRPr>
+            </a:pPr>
+            <a:r>
+              <a:t>groundedness · relevance · task adherence · tool-call accuracy · intent resolution · condition checks</a:t>
             </a:r>
           </a:p>
         </p:txBody>

</xml_diff>

<commit_message>
docs(workshop): align guided labs with rehearsal evidence
Keep the participant core concise, move optional detail into expandable sections, align learning outcomes and slides, and document private-link operation and the saved-history limitation.

Co-authored-by: Copilot App <223556219+Copilot@users.noreply.github.com>
</commit_message>
<xml_diff>
--- a/deck/LiveWell-Foundry-Workshop-Day1.pptx
+++ b/deck/LiveWell-Foundry-Workshop-Day1.pptx
@@ -941,7 +941,7 @@
           <a:lstStyle/>
           <a:p>
             <a:r>
-              <a:t>Do not present these as competing products. Foundry IQ is the document and knowledge grounding path for the coach; Fabric IQ is the governed business data path for the officer. Use the examples row to show that Rahim's guidance stays in Foundry IQ; Fabric only answers aggregate questions, from Mei Lin or from Rahim's one age-band cohort question. Gate: move on when participants can choose the correct IQ for a new prompt.</a:t>
+              <a:t>Do not present these as competing products. These are the workshop's design choices, not exclusive product capabilities. Fabric ontology supplies context; the underlying source executes SQL, KQL or DAX. Use the examples row to show that Rahim's guidance stays in Foundry IQ; Fabric only answers aggregate questions, from Mei Lin or from Rahim's one age-band cohort question. Gate: move on when participants can choose the correct IQ for a new prompt.</a:t>
             </a:r>
           </a:p>
         </p:txBody>
@@ -1081,7 +1081,7 @@
           <a:lstStyle/>
           <a:p>
             <a:r>
-              <a:t>Run the default and custom ladder live if the environment is healthy; otherwise use the pre-captured traces. The result columns are the expected outcomes from Lab 2: the custom policy moves guardrail blocks from 1 of 7 to 4 of 7. Explain block versus annotate: at or above the threshold the request is blocked (HTTP 400, red banner, Failed trace); below it the answer goes through and the severity is recorded. The dose-reminder row is the cost of a stricter control. Gate: move on when every table has at least one production policy they would require.</a:t>
+              <a:t>The table illustrates historical outcomes, not guaranteed classifications. Keep prompts unchanged, inspect the actual filter and stage, and report differences rather than retrying for a desired result. Explain block versus annotate: at or above the threshold the request is blocked (HTTP 400, red banner, Failed trace); below it the answer goes through and the severity is recorded. The dose-reminder row is the cost of a stricter control. Gate: move on when every table has at least one production policy they would require.</a:t>
             </a:r>
           </a:p>
         </p:txBody>
@@ -5385,7 +5385,7 @@
               </a:defRPr>
             </a:pPr>
             <a:r>
-              <a:t>40 min</a:t>
+              <a:t>30 min</a:t>
             </a:r>
           </a:p>
         </p:txBody>
@@ -5567,7 +5567,7 @@
               </a:defRPr>
             </a:pPr>
             <a:r>
-              <a:t>Govern · Navigator + Builder</a:t>
+              <a:t>Guided comparison · Navigator + Builder</a:t>
             </a:r>
           </a:p>
         </p:txBody>
@@ -5711,7 +5711,7 @@
               </a:defRPr>
             </a:pPr>
             <a:r>
-              <a:t>Safety is measured, not assumed: apply guardrails, prove behaviour with evaluators, and make every decision auditable in a trace</a:t>
+              <a:t>Compare safety layers using traces and prepared evaluation results; distinguish a refusal, a block, an over-block and an unavailable verdict</a:t>
             </a:r>
           </a:p>
         </p:txBody>
@@ -5855,7 +5855,7 @@
               </a:defRPr>
             </a:pPr>
             <a:r>
-              <a:t>The ladder shows which layer catches each prompt (blocklist, self-harm at Low, Prompt Shields, instructions), a blocked run appears as Failed in Traces, and you can read the v1 vs v2 handled_safely result from the prepared evaluation.</a:t>
+              <a:t>Identify the responsible layer; compare prepared same-model demo runs, distinguishing pass/fail from error/not scored. These are not participant-agent evaluations.</a:t>
             </a:r>
           </a:p>
         </p:txBody>
@@ -6169,7 +6169,7 @@
               </a:defRPr>
             </a:pPr>
             <a:r>
-              <a:t>40 min</a:t>
+              <a:t>30 min</a:t>
             </a:r>
           </a:p>
         </p:txBody>
@@ -6639,7 +6639,7 @@
               </a:defRPr>
             </a:pPr>
             <a:r>
-              <a:t>A compound question calls the profile tool and activities MCP, tailors to Rahim, and waits for approval before register_interest.</a:t>
+              <a:t>Inspect profile and activity calls; approve or deny the proposed write explicitly. Memory has stored/search evidence. Fixed synthetic Rahim, no real booking.</a:t>
             </a:r>
           </a:p>
         </p:txBody>
@@ -6953,7 +6953,7 @@
               </a:defRPr>
             </a:pPr>
             <a:r>
-              <a:t>15 min</a:t>
+              <a:t>10 min</a:t>
             </a:r>
           </a:p>
         </p:txBody>
@@ -7135,7 +7135,7 @@
               </a:defRPr>
             </a:pPr>
             <a:r>
-              <a:t>Optional · gated on FABRIC_BRIDGE=true</a:t>
+              <a:t>Optional · only when capacity and access are ready</a:t>
             </a:r>
           </a:p>
         </p:txBody>
@@ -7279,7 +7279,7 @@
               </a:defRPr>
             </a:pPr>
             <a:r>
-              <a:t>Continues Lab 3: add governed population evidence to a personal answer, without sending personal data</a:t>
+              <a:t>Use governed cohort evidence when guidance alone cannot answer a question, and inspect exactly what information the coach sends to Fabric</a:t>
             </a:r>
           </a:p>
         </p:txBody>
@@ -7423,7 +7423,7 @@
               </a:defRPr>
             </a:pPr>
             <a:r>
-              <a:t>Programme fit chains profile → Fabric IQ (age band only) → activities with approval; Mei's trace shows Fabric IQ; Rahim's food question makes no Fabric call.</a:t>
+              <a:t>Compare an aggregate question with guide retrieval and inspect userQuestion. Programme fit is a further optional extension; paused capacity can stay paused.</a:t>
             </a:r>
           </a:p>
         </p:txBody>
@@ -7792,7 +7792,7 @@
               </a:defRPr>
             </a:pPr>
             <a:r>
-              <a:t>Builder</a:t>
+              <a:t>Navigator / Builder</a:t>
             </a:r>
           </a:p>
         </p:txBody>
@@ -7919,7 +7919,7 @@
               </a:defRPr>
             </a:pPr>
             <a:r>
-              <a:t>Engineer appendix · facilitator demo</a:t>
+              <a:t>Guided browser comparison · optional Builder appendix</a:t>
             </a:r>
           </a:p>
         </p:txBody>
@@ -7991,7 +7991,7 @@
               </a:defRPr>
             </a:pPr>
             <a:r>
-              <a:t>LiveWell Coach goes live behind the simulated Healthy 365 channel.</a:t>
+              <a:t>Rahim's week plan and activity-only request reveal different routing choices.</a:t>
             </a:r>
           </a:p>
         </p:txBody>
@@ -8063,7 +8063,7 @@
               </a:defRPr>
             </a:pPr>
             <a:r>
-              <a:t>From playground to production: the same agent behind two doors (portal for people, endpoint for systems), governed by the same policy</a:t>
+              <a:t>Choose between one agent, sequential and hand-off workflows; use execution evidence to explain the route, then inspect the pre-deployed hosted team</a:t>
             </a:r>
           </a:p>
         </p:txBody>
@@ -8135,7 +8135,7 @@
               </a:defRPr>
             </a:pPr>
             <a:r>
-              <a:t>Agent Framework sequential and hand-off orchestration in DevUI; Programme-Insights specialist; azd deploy (code deploy); rai_config; hosted tracing.</a:t>
+              <a:t>Prebuilt Agent Framework teams; DevUI graph, outputs and hand-off calls; existing hosted trace and guardrail proof. Fabric specialist optional.</a:t>
             </a:r>
           </a:p>
         </p:txBody>
@@ -8207,7 +8207,7 @@
               </a:defRPr>
             </a:pPr>
             <a:r>
-              <a:t>Sequential and hand-off runs are visible in DevUI; the hosted endpoint returns JSON and blocks a blocklisted prompt; hosted and playground traces compared.</a:t>
+              <a:t>Explain when one agent is enough, identify a hand-off call and the final answerer, and recognise the hosted sequential team. No participant provisioning.</a:t>
             </a:r>
           </a:p>
         </p:txBody>
@@ -10476,7 +10476,7 @@
               </a:defRPr>
             </a:pPr>
             <a:r>
-              <a:t>Guardrail &amp; evaluation scorecard</a:t>
+              <a:t>Guardrail scorecard — captured examples</a:t>
             </a:r>
           </a:p>
         </p:txBody>
@@ -11723,7 +11723,7 @@
               </a:defRPr>
             </a:pPr>
             <a:r>
-              <a:t>Evaluators (facilitator pre-run, look-only)</a:t>
+              <a:t>Prepared evaluation: look only</a:t>
             </a:r>
           </a:p>
           <a:p>
@@ -11736,7 +11736,7 @@
               </a:defRPr>
             </a:pPr>
             <a:r>
-              <a:t>The prepared run scores guardrail_blocked, handled_safely (LLM judge) and self_harm. Built-in families to know: groundedness · relevance · task adherence · tool-call accuracy · intent resolution</a:t>
+              <a:t>Compare default/custom for the same model. Pass, fail and not scored are different. A judge error is not an unsafe-answer verdict. These are demo runs, not your agent versions.</a:t>
             </a:r>
           </a:p>
         </p:txBody>
@@ -14812,7 +14812,7 @@
                           </a:solidFill>
                           <a:latin typeface="Segoe UI"/>
                         </a:rPr>
-                        <a:t>SDK agents, versioning, orchestration patterns</a:t>
+                        <a:t>Choose a pattern; inspect execution evidence</a:t>
                       </a:r>
                     </a:p>
                   </a:txBody>
@@ -14842,7 +14842,7 @@
                           </a:solidFill>
                           <a:latin typeface="Segoe UI"/>
                         </a:rPr>
-                        <a:t>Lab 1 walkthrough; preview Lab 3 Builder code</a:t>
+                        <a:t>Lab 4 shared DevUI comparison (25); code and discussion (15)</a:t>
                       </a:r>
                     </a:p>
                   </a:txBody>
@@ -15452,7 +15452,7 @@
                           </a:solidFill>
                           <a:latin typeface="Segoe UI"/>
                         </a:rPr>
-                        <a:t>Lab 3 incl. Fabric step; Lab 4 demo; bridge; close</a:t>
+                        <a:t>Lab 3; optional Fabric; Lab 4 pre-deployed hosted proof at 5:15; close</a:t>
                       </a:r>
                     </a:p>
                   </a:txBody>
@@ -22135,7 +22135,7 @@
               </a:defRPr>
             </a:pPr>
             <a:r>
-              <a:t>A Foundry agent is a model plus instructions, and instructions alone can make it safe; every answer leaves a trace you can inspect</a:t>
+              <a:t>Configure an agent's intended behaviour with a model and instructions, then inspect a response and its trace; one refusal is not proof of safety</a:t>
             </a:r>
           </a:p>
         </p:txBody>
@@ -22279,7 +22279,7 @@
               </a:defRPr>
             </a:pPr>
             <a:r>
-              <a:t>Agent introduces itself, says it is not a doctor and refuses to diagnose; the trace shows one gpt-5-mini call and its tokens.</a:t>
+              <a:t>Inspect the introduction, refusal and model-call trace. Explain why this example is not a safety guarantee.</a:t>
             </a:r>
           </a:p>
         </p:txBody>
@@ -22593,7 +22593,7 @@
               </a:defRPr>
             </a:pPr>
             <a:r>
-              <a:t>40 min</a:t>
+              <a:t>35 min</a:t>
             </a:r>
           </a:p>
         </p:txBody>
@@ -23063,7 +23063,7 @@
               </a:defRPr>
             </a:pPr>
             <a:r>
-              <a:t>Pre-diabetes food question cites at least one KB document; the supplement question routes to a clinician with no invented source.</a:t>
+              <a:t>Connect a food-advice claim to a retrieved passage; explain the no-source clinician route. Optional intake uses its own agent/schema.</a:t>
             </a:r>
           </a:p>
         </p:txBody>

</xml_diff>